<commit_message>
Modul PPT Opto P1: ilustrasi diperbarui & Daftar Pustaka disamakan dgn Word
Gambar-gambar konten (9 slide) dibangun ulang dari fig_lib.py versi
terbaru (font sedikit lebih kecil, legend/label yang sebelumnya
overlap/terpotong sudah diperbaiki, layout roadmap lebih compact) --
identik dgn perbaikan yang sudah masuk ke Modul Word. Untuk 2 ilustrasi
varian vertikal khusus PPT (roadmap & analogi kolom sempit-tinggi),
ukuran font judul/label diperkecil sedikit agar konsisten dgn prinsip
"sedikit perkecil ukuran teks" dan diverifikasi tidak ada overlap/
terpotong. Slide Daftar Pustaka diganti dgn 7 referensi terverifikasi
yang sama dgn Modul Word (semua <=10 tahun, 5 jurnal internasional
ber-DOI), menggantikan referensi lama yang sudah >10 tahun.

Verifikasi otomatis: validate.py PASSED, 0 shape overlap di 9 slide
konten, semua 9 judul slide muat 1 baris, 0 em-dash.
</commit_message>
<xml_diff>
--- a/Optimalisasi-dan-Automasi/Modul-Word/Modul-1-Pengantar-Time-Series-Data.pptx
+++ b/Optimalisasi-dan-Automasi/Modul-Word/Modul-1-Pengantar-Time-Series-Data.pptx
@@ -12566,8 +12566,8 @@
         </p:blipFill>
         <p:spPr>
           <a:xfrm>
-            <a:off x="7911854" y="1931991"/>
-            <a:ext cx="3441945" cy="3661643"/>
+            <a:off x="7911854" y="2405470"/>
+            <a:ext cx="3441945" cy="2714685"/>
           </a:xfrm>
           <a:prstGeom prst="rect">
             <a:avLst/>
@@ -13015,8 +13015,8 @@
         </p:blipFill>
         <p:spPr>
           <a:xfrm>
-            <a:off x="7911854" y="2344672"/>
-            <a:ext cx="3441945" cy="2836280"/>
+            <a:off x="7911854" y="2675630"/>
+            <a:ext cx="3441945" cy="2174364"/>
           </a:xfrm>
           <a:prstGeom prst="rect">
             <a:avLst/>
@@ -13161,7 +13161,7 @@
             </a:pPr>
             <a:r>
               <a:rPr sz="1200"/>
-              <a:t>Box, G. E. P., &amp; Cox, D. R. (1964). An analysis of transformations. Journal of the Royal Statistical Society: Series B, 26(2), 211–252.</a:t>
+              <a:t>Altaf, M., Akram, T., Khan, M. A., Iqbal, M., Ch, M. M. I., &amp; Hsu, C.-H. (2022). A new statistical features based approach for bearing fault diagnosis using vibration signals. Sensors, 22(5), 2012. https://doi.org/10.3390/s22052012</a:t>
             </a:r>
             <a:endParaRPr/>
           </a:p>
@@ -13173,7 +13173,7 @@
             </a:pPr>
             <a:r>
               <a:rPr sz="1200"/>
-              <a:t>Cleveland, R. B., Cleveland, W. S., McRae, J. E., &amp; Terpenning, I. (1990). STL: A seasonal-trend decomposition procedure based on loess. Journal of Official Statistics, 6(1), 3–73.</a:t>
+              <a:t>Dudek, G. (2023). STD: A seasonal-trend-dispersion decomposition of time series. IEEE Transactions on Knowledge and Data Engineering, 35(10), 10339–10350. https://doi.org/10.1109/TKDE.2023.3268125</a:t>
             </a:r>
           </a:p>
           <a:p>
@@ -13195,7 +13195,7 @@
             </a:pPr>
             <a:r>
               <a:rPr sz="1200"/>
-              <a:t>Mohanty, A. R. (2015). Machinery Condition Monitoring: Principles and Practices. CRC Press.</a:t>
+              <a:t>Romanssini, M., de Aguirre, P. C. C., Compassi-Severo, L., &amp; Girardi, A. G. (2023). A review on vibration monitoring techniques for predictive maintenance of rotating machinery. Eng, 4(3), 1797–1817. https://doi.org/10.3390/eng4030102</a:t>
             </a:r>
           </a:p>
           <a:p>
@@ -13206,7 +13206,7 @@
             </a:pPr>
             <a:r>
               <a:rPr sz="1200"/>
-              <a:t>Seabold, S., &amp; Perktold, J. (2010). Statsmodels: Econometric and statistical modeling with Python. Proc. 9th Python in Science Conf. https://www.statsmodels.org/stable/tsa.html</a:t>
+              <a:t>Tiboni, M., Remino, C., Bussola, R., &amp; Amici, C. (2022). A review on vibration-based condition monitoring of rotating machinery. Applied Sciences, 12(3), 972. https://doi.org/10.3390/app12030972</a:t>
             </a:r>
           </a:p>
           <a:p>
@@ -13217,7 +13217,18 @@
             </a:pPr>
             <a:r>
               <a:rPr sz="1200"/>
-              <a:t>Pedregosa, F., et al. (2011). Scikit-learn: Machine learning in Python. JMLR, 12, 2825–2830. https://scikit-learn.org/stable/modules/preprocessing.html</a:t>
+              <a:t>Ul Hassan, I., Panduru, K., &amp; Walsh, J. (2024). An in-depth study of vibration sensors for condition monitoring. Sensors, 24(3), 740. https://doi.org/10.3390/s24030740</a:t>
+            </a:r>
+          </a:p>
+          <a:p>
+            <a:pPr>
+              <a:spcAft>
+                <a:spcPts val="600"/>
+              </a:spcAft>
+            </a:pPr>
+            <a:r>
+              <a:rPr sz="1200"/>
+              <a:t>Zeng, A., Chen, M., Zhang, L., &amp; Xu, Q. (2023). Are transformers effective for time series forecasting? Proceedings of the AAAI Conference on Artificial Intelligence, 37(9), 11121–11128. https://doi.org/10.1609/aaai.v37i9.26317</a:t>
             </a:r>
           </a:p>
         </p:txBody>
@@ -15153,8 +15164,8 @@
         </p:blipFill>
         <p:spPr>
           <a:xfrm>
-            <a:off x="8164020" y="1825625"/>
-            <a:ext cx="2937612" cy="3874375"/>
+            <a:off x="8174535" y="1825625"/>
+            <a:ext cx="2916583" cy="3874375"/>
           </a:xfrm>
           <a:prstGeom prst="rect">
             <a:avLst/>
@@ -15587,8 +15598,8 @@
         </p:blipFill>
         <p:spPr>
           <a:xfrm>
-            <a:off x="7911854" y="2368583"/>
-            <a:ext cx="3441945" cy="2788458"/>
+            <a:off x="7911854" y="2544325"/>
+            <a:ext cx="3441945" cy="2436974"/>
           </a:xfrm>
           <a:prstGeom prst="rect">
             <a:avLst/>
@@ -16036,8 +16047,8 @@
         </p:blipFill>
         <p:spPr>
           <a:xfrm>
-            <a:off x="8047358" y="1825625"/>
-            <a:ext cx="3170937" cy="3874375"/>
+            <a:off x="7994093" y="1825625"/>
+            <a:ext cx="3277467" cy="3874375"/>
           </a:xfrm>
           <a:prstGeom prst="rect">
             <a:avLst/>
@@ -16485,8 +16496,8 @@
         </p:blipFill>
         <p:spPr>
           <a:xfrm>
-            <a:off x="7911854" y="2501307"/>
-            <a:ext cx="3441945" cy="2523010"/>
+            <a:off x="7911854" y="2489690"/>
+            <a:ext cx="3441945" cy="2546244"/>
           </a:xfrm>
           <a:prstGeom prst="rect">
             <a:avLst/>
@@ -16919,8 +16930,8 @@
         </p:blipFill>
         <p:spPr>
           <a:xfrm>
-            <a:off x="7911854" y="2496945"/>
-            <a:ext cx="3441945" cy="2531734"/>
+            <a:off x="7911854" y="2320427"/>
+            <a:ext cx="3441945" cy="2884771"/>
           </a:xfrm>
           <a:prstGeom prst="rect">
             <a:avLst/>
@@ -17368,8 +17379,8 @@
         </p:blipFill>
         <p:spPr>
           <a:xfrm>
-            <a:off x="8311215" y="1825625"/>
-            <a:ext cx="2643223" cy="3874375"/>
+            <a:off x="8325661" y="1825625"/>
+            <a:ext cx="2614330" cy="3874375"/>
           </a:xfrm>
           <a:prstGeom prst="rect">
             <a:avLst/>
@@ -17802,8 +17813,8 @@
         </p:blipFill>
         <p:spPr>
           <a:xfrm>
-            <a:off x="7911854" y="2151770"/>
-            <a:ext cx="3441945" cy="3222085"/>
+            <a:off x="7911854" y="2491991"/>
+            <a:ext cx="3441945" cy="2541643"/>
           </a:xfrm>
           <a:prstGeom prst="rect">
             <a:avLst/>

</xml_diff>

<commit_message>
Modul PPT Opto P1: ilustrasi diperbarui & Daftar Pustaka disamakan dgn Word (#638)
Gambar-gambar konten (9 slide) dibangun ulang dari fig_lib.py versi
terbaru (font sedikit lebih kecil, legend/label yang sebelumnya
overlap/terpotong sudah diperbaiki, layout roadmap lebih compact) --
identik dgn perbaikan yang sudah masuk ke Modul Word. Untuk 2 ilustrasi
varian vertikal khusus PPT (roadmap & analogi kolom sempit-tinggi),
ukuran font judul/label diperkecil sedikit agar konsisten dgn prinsip
"sedikit perkecil ukuran teks" dan diverifikasi tidak ada overlap/
terpotong. Slide Daftar Pustaka diganti dgn 7 referensi terverifikasi
yang sama dgn Modul Word (semua <=10 tahun, 5 jurnal internasional
ber-DOI), menggantikan referensi lama yang sudah >10 tahun.

Verifikasi otomatis: validate.py PASSED, 0 shape overlap di 9 slide
konten, semua 9 judul slide muat 1 baris, 0 em-dash.

Co-authored-by: Claude <noreply@anthropic.com>
</commit_message>
<xml_diff>
--- a/Optimalisasi-dan-Automasi/Modul-Word/Modul-1-Pengantar-Time-Series-Data.pptx
+++ b/Optimalisasi-dan-Automasi/Modul-Word/Modul-1-Pengantar-Time-Series-Data.pptx
@@ -12566,8 +12566,8 @@
         </p:blipFill>
         <p:spPr>
           <a:xfrm>
-            <a:off x="7911854" y="1931991"/>
-            <a:ext cx="3441945" cy="3661643"/>
+            <a:off x="7911854" y="2405470"/>
+            <a:ext cx="3441945" cy="2714685"/>
           </a:xfrm>
           <a:prstGeom prst="rect">
             <a:avLst/>
@@ -13015,8 +13015,8 @@
         </p:blipFill>
         <p:spPr>
           <a:xfrm>
-            <a:off x="7911854" y="2344672"/>
-            <a:ext cx="3441945" cy="2836280"/>
+            <a:off x="7911854" y="2675630"/>
+            <a:ext cx="3441945" cy="2174364"/>
           </a:xfrm>
           <a:prstGeom prst="rect">
             <a:avLst/>
@@ -13161,7 +13161,7 @@
             </a:pPr>
             <a:r>
               <a:rPr sz="1200"/>
-              <a:t>Box, G. E. P., &amp; Cox, D. R. (1964). An analysis of transformations. Journal of the Royal Statistical Society: Series B, 26(2), 211–252.</a:t>
+              <a:t>Altaf, M., Akram, T., Khan, M. A., Iqbal, M., Ch, M. M. I., &amp; Hsu, C.-H. (2022). A new statistical features based approach for bearing fault diagnosis using vibration signals. Sensors, 22(5), 2012. https://doi.org/10.3390/s22052012</a:t>
             </a:r>
             <a:endParaRPr/>
           </a:p>
@@ -13173,7 +13173,7 @@
             </a:pPr>
             <a:r>
               <a:rPr sz="1200"/>
-              <a:t>Cleveland, R. B., Cleveland, W. S., McRae, J. E., &amp; Terpenning, I. (1990). STL: A seasonal-trend decomposition procedure based on loess. Journal of Official Statistics, 6(1), 3–73.</a:t>
+              <a:t>Dudek, G. (2023). STD: A seasonal-trend-dispersion decomposition of time series. IEEE Transactions on Knowledge and Data Engineering, 35(10), 10339–10350. https://doi.org/10.1109/TKDE.2023.3268125</a:t>
             </a:r>
           </a:p>
           <a:p>
@@ -13195,7 +13195,7 @@
             </a:pPr>
             <a:r>
               <a:rPr sz="1200"/>
-              <a:t>Mohanty, A. R. (2015). Machinery Condition Monitoring: Principles and Practices. CRC Press.</a:t>
+              <a:t>Romanssini, M., de Aguirre, P. C. C., Compassi-Severo, L., &amp; Girardi, A. G. (2023). A review on vibration monitoring techniques for predictive maintenance of rotating machinery. Eng, 4(3), 1797–1817. https://doi.org/10.3390/eng4030102</a:t>
             </a:r>
           </a:p>
           <a:p>
@@ -13206,7 +13206,7 @@
             </a:pPr>
             <a:r>
               <a:rPr sz="1200"/>
-              <a:t>Seabold, S., &amp; Perktold, J. (2010). Statsmodels: Econometric and statistical modeling with Python. Proc. 9th Python in Science Conf. https://www.statsmodels.org/stable/tsa.html</a:t>
+              <a:t>Tiboni, M., Remino, C., Bussola, R., &amp; Amici, C. (2022). A review on vibration-based condition monitoring of rotating machinery. Applied Sciences, 12(3), 972. https://doi.org/10.3390/app12030972</a:t>
             </a:r>
           </a:p>
           <a:p>
@@ -13217,7 +13217,18 @@
             </a:pPr>
             <a:r>
               <a:rPr sz="1200"/>
-              <a:t>Pedregosa, F., et al. (2011). Scikit-learn: Machine learning in Python. JMLR, 12, 2825–2830. https://scikit-learn.org/stable/modules/preprocessing.html</a:t>
+              <a:t>Ul Hassan, I., Panduru, K., &amp; Walsh, J. (2024). An in-depth study of vibration sensors for condition monitoring. Sensors, 24(3), 740. https://doi.org/10.3390/s24030740</a:t>
+            </a:r>
+          </a:p>
+          <a:p>
+            <a:pPr>
+              <a:spcAft>
+                <a:spcPts val="600"/>
+              </a:spcAft>
+            </a:pPr>
+            <a:r>
+              <a:rPr sz="1200"/>
+              <a:t>Zeng, A., Chen, M., Zhang, L., &amp; Xu, Q. (2023). Are transformers effective for time series forecasting? Proceedings of the AAAI Conference on Artificial Intelligence, 37(9), 11121–11128. https://doi.org/10.1609/aaai.v37i9.26317</a:t>
             </a:r>
           </a:p>
         </p:txBody>
@@ -15153,8 +15164,8 @@
         </p:blipFill>
         <p:spPr>
           <a:xfrm>
-            <a:off x="8164020" y="1825625"/>
-            <a:ext cx="2937612" cy="3874375"/>
+            <a:off x="8174535" y="1825625"/>
+            <a:ext cx="2916583" cy="3874375"/>
           </a:xfrm>
           <a:prstGeom prst="rect">
             <a:avLst/>
@@ -15587,8 +15598,8 @@
         </p:blipFill>
         <p:spPr>
           <a:xfrm>
-            <a:off x="7911854" y="2368583"/>
-            <a:ext cx="3441945" cy="2788458"/>
+            <a:off x="7911854" y="2544325"/>
+            <a:ext cx="3441945" cy="2436974"/>
           </a:xfrm>
           <a:prstGeom prst="rect">
             <a:avLst/>
@@ -16036,8 +16047,8 @@
         </p:blipFill>
         <p:spPr>
           <a:xfrm>
-            <a:off x="8047358" y="1825625"/>
-            <a:ext cx="3170937" cy="3874375"/>
+            <a:off x="7994093" y="1825625"/>
+            <a:ext cx="3277467" cy="3874375"/>
           </a:xfrm>
           <a:prstGeom prst="rect">
             <a:avLst/>
@@ -16485,8 +16496,8 @@
         </p:blipFill>
         <p:spPr>
           <a:xfrm>
-            <a:off x="7911854" y="2501307"/>
-            <a:ext cx="3441945" cy="2523010"/>
+            <a:off x="7911854" y="2489690"/>
+            <a:ext cx="3441945" cy="2546244"/>
           </a:xfrm>
           <a:prstGeom prst="rect">
             <a:avLst/>
@@ -16919,8 +16930,8 @@
         </p:blipFill>
         <p:spPr>
           <a:xfrm>
-            <a:off x="7911854" y="2496945"/>
-            <a:ext cx="3441945" cy="2531734"/>
+            <a:off x="7911854" y="2320427"/>
+            <a:ext cx="3441945" cy="2884771"/>
           </a:xfrm>
           <a:prstGeom prst="rect">
             <a:avLst/>
@@ -17368,8 +17379,8 @@
         </p:blipFill>
         <p:spPr>
           <a:xfrm>
-            <a:off x="8311215" y="1825625"/>
-            <a:ext cx="2643223" cy="3874375"/>
+            <a:off x="8325661" y="1825625"/>
+            <a:ext cx="2614330" cy="3874375"/>
           </a:xfrm>
           <a:prstGeom prst="rect">
             <a:avLst/>
@@ -17802,8 +17813,8 @@
         </p:blipFill>
         <p:spPr>
           <a:xfrm>
-            <a:off x="7911854" y="2151770"/>
-            <a:ext cx="3441945" cy="3222085"/>
+            <a:off x="7911854" y="2491991"/>
+            <a:ext cx="3441945" cy="2541643"/>
           </a:xfrm>
           <a:prstGeom prst="rect">
             <a:avLst/>

</xml_diff>